<commit_message>
Exercise deck: closing slide, AI is not a technology project
Co-Authored-By: Claude Fable 5.1 <noreply@anthropic.com>
Claude-Session: https://claude.ai/code/session_013LaU8KutyVc6GAVj7UGghE
</commit_message>
<xml_diff>
--- a/slides/agent-challenge-hr.pptx
+++ b/slides/agent-challenge-hr.pptx
@@ -33,6 +33,7 @@
     <p:sldId id="278" r:id="rId29"/>
     <p:sldId id="279" r:id="rId30"/>
     <p:sldId id="280" r:id="rId31"/>
+    <p:sldId id="281" r:id="rId32"/>
   </p:sldIdLst>
   <p:sldSz cx="12192000" cy="6858000"/>
   <p:notesSz cx="6858000" cy="9144000"/>
@@ -2151,6 +2152,76 @@
 </p:notes>
 </file>
 
+<file path=ppt/notesSlides/notesSlide26.xml><?xml version="1.0" encoding="utf-8"?>
+<p:notes xmlns:a="http://schemas.openxmlformats.org/drawingml/2006/main" xmlns:p="http://schemas.openxmlformats.org/presentationml/2006/main" xmlns:r="http://schemas.openxmlformats.org/officeDocument/2006/relationships">
+  <p:cSld>
+    <p:spTree>
+      <p:nvGrpSpPr>
+        <p:cNvPr id="1" name=""/>
+        <p:cNvGrpSpPr/>
+        <p:nvPr/>
+      </p:nvGrpSpPr>
+      <p:grpSpPr>
+        <a:xfrm>
+          <a:off x="0" y="0"/>
+          <a:ext cx="0" cy="0"/>
+          <a:chOff x="0" y="0"/>
+          <a:chExt cx="0" cy="0"/>
+        </a:xfrm>
+      </p:grpSpPr>
+      <p:sp>
+        <p:nvSpPr>
+          <p:cNvPr id="2" name="Slide Image Placeholder 1"/>
+          <p:cNvSpPr>
+            <a:spLocks noGrp="1"/>
+          </p:cNvSpPr>
+          <p:nvPr>
+            <p:ph type="sldImg" idx="2"/>
+          </p:nvPr>
+        </p:nvSpPr>
+        <p:spPr/>
+      </p:sp>
+      <p:sp>
+        <p:nvSpPr>
+          <p:cNvPr id="3" name="Notes Placeholder 2"/>
+          <p:cNvSpPr>
+            <a:spLocks noGrp="1"/>
+          </p:cNvSpPr>
+          <p:nvPr>
+            <p:ph type="body" idx="3" sz="quarter"/>
+          </p:nvPr>
+        </p:nvSpPr>
+        <p:spPr/>
+        <p:txBody>
+          <a:bodyPr/>
+          <a:lstStyle/>
+          <a:p>
+            <a:r>
+              <a:t>Close on the operating model. Everything in the session came back to ownership, governance and behaviour: who writes the brief, who owns the rules, who signs above the limit, what is measured. The tools were the least of it.</a:t>
+            </a:r>
+          </a:p>
+        </p:txBody>
+      </p:sp>
+      <p:sp>
+        <p:nvSpPr>
+          <p:cNvPr id="4" name="Slide Number Placeholder 3"/>
+          <p:cNvSpPr>
+            <a:spLocks noGrp="1"/>
+          </p:cNvSpPr>
+          <p:nvPr>
+            <p:ph type="sldNum" idx="5" sz="quarter"/>
+          </p:nvPr>
+        </p:nvSpPr>
+        <p:spPr/>
+      </p:sp>
+    </p:spTree>
+  </p:cSld>
+  <p:clrMapOvr>
+    <a:masterClrMapping/>
+  </p:clrMapOvr>
+</p:notes>
+</file>
+
 <file path=ppt/notesSlides/notesSlide3.xml><?xml version="1.0" encoding="utf-8"?>
 <p:notes xmlns:a="http://schemas.openxmlformats.org/drawingml/2006/main" xmlns:p="http://schemas.openxmlformats.org/presentationml/2006/main" xmlns:r="http://schemas.openxmlformats.org/officeDocument/2006/relationships">
   <p:cSld>
@@ -28628,6 +28699,624 @@
                 <a:latin typeface="Arial"/>
               </a:rPr>
               <a:t>Close by asking each group for the one thing they would need from the organisation to build what they mapped.</a:t>
+            </a:r>
+          </a:p>
+        </p:txBody>
+      </p:sp>
+    </p:spTree>
+  </p:cSld>
+  <p:clrMapOvr>
+    <a:masterClrMapping/>
+  </p:clrMapOvr>
+</p:sld>
+</file>
+
+<file path=ppt/slides/slide26.xml><?xml version="1.0" encoding="utf-8"?>
+<p:sld xmlns:a="http://schemas.openxmlformats.org/drawingml/2006/main" xmlns:p="http://schemas.openxmlformats.org/presentationml/2006/main" xmlns:r="http://schemas.openxmlformats.org/officeDocument/2006/relationships">
+  <p:cSld>
+    <p:spTree>
+      <p:nvGrpSpPr>
+        <p:cNvPr id="1" name=""/>
+        <p:cNvGrpSpPr/>
+        <p:nvPr/>
+      </p:nvGrpSpPr>
+      <p:grpSpPr/>
+      <p:sp>
+        <p:nvSpPr>
+          <p:cNvPr id="2" name="TextBox 1"/>
+          <p:cNvSpPr txBox="1"/>
+          <p:nvPr/>
+        </p:nvSpPr>
+        <p:spPr>
+          <a:xfrm>
+            <a:off x="9893808" y="6492240"/>
+            <a:ext cx="2084831" cy="274320"/>
+          </a:xfrm>
+          <a:prstGeom prst="rect">
+            <a:avLst/>
+          </a:prstGeom>
+          <a:noFill/>
+        </p:spPr>
+        <p:txBody>
+          <a:bodyPr wrap="square" anchor="t">
+            <a:spAutoFit/>
+          </a:bodyPr>
+          <a:lstStyle/>
+          <a:p>
+            <a:pPr algn="r">
+              <a:spcAft>
+                <a:spcPts val="400"/>
+              </a:spcAft>
+            </a:pPr>
+            <a:r>
+              <a:rPr sz="1000" b="0" i="0">
+                <a:solidFill>
+                  <a:srgbClr val="6B7280"/>
+                </a:solidFill>
+                <a:latin typeface="Arial"/>
+              </a:rPr>
+              <a:t>26</a:t>
+            </a:r>
+          </a:p>
+        </p:txBody>
+      </p:sp>
+      <p:sp>
+        <p:nvSpPr>
+          <p:cNvPr id="3" name="TextBox 2"/>
+          <p:cNvSpPr txBox="1"/>
+          <p:nvPr/>
+        </p:nvSpPr>
+        <p:spPr>
+          <a:xfrm>
+            <a:off x="731520" y="502920"/>
+            <a:ext cx="10789920" cy="1097280"/>
+          </a:xfrm>
+          <a:prstGeom prst="rect">
+            <a:avLst/>
+          </a:prstGeom>
+          <a:noFill/>
+        </p:spPr>
+        <p:txBody>
+          <a:bodyPr wrap="square" anchor="ctr">
+            <a:spAutoFit/>
+          </a:bodyPr>
+          <a:lstStyle/>
+          <a:p>
+            <a:r>
+              <a:rPr sz="4400" b="1" i="0">
+                <a:solidFill>
+                  <a:srgbClr val="1F2A5C"/>
+                </a:solidFill>
+                <a:latin typeface="Arial"/>
+              </a:rPr>
+              <a:t>AI IS NOT A </a:t>
+            </a:r>
+            <a:r>
+              <a:rPr sz="4400" b="1" i="0">
+                <a:solidFill>
+                  <a:srgbClr val="CE9A2B"/>
+                </a:solidFill>
+                <a:latin typeface="Arial"/>
+              </a:rPr>
+              <a:t>TECHNOLOGY PROJECT</a:t>
+            </a:r>
+          </a:p>
+        </p:txBody>
+      </p:sp>
+      <p:sp>
+        <p:nvSpPr>
+          <p:cNvPr id="4" name="TextBox 3"/>
+          <p:cNvSpPr txBox="1"/>
+          <p:nvPr/>
+        </p:nvSpPr>
+        <p:spPr>
+          <a:xfrm>
+            <a:off x="731520" y="1783080"/>
+            <a:ext cx="10607040" cy="914400"/>
+          </a:xfrm>
+          <a:prstGeom prst="rect">
+            <a:avLst/>
+          </a:prstGeom>
+          <a:noFill/>
+        </p:spPr>
+        <p:txBody>
+          <a:bodyPr wrap="square" anchor="t">
+            <a:spAutoFit/>
+          </a:bodyPr>
+          <a:lstStyle/>
+          <a:p>
+            <a:pPr algn="l">
+              <a:spcAft>
+                <a:spcPts val="400"/>
+              </a:spcAft>
+            </a:pPr>
+            <a:r>
+              <a:rPr sz="1700" b="0" i="0">
+                <a:solidFill>
+                  <a:srgbClr val="1F2A5C"/>
+                </a:solidFill>
+                <a:latin typeface="Arial"/>
+              </a:rPr>
+              <a:t>The real question isn't which tool to buy, but who owns it, how to govern it, and how to change the way thousands of people work. Adoption at scale is an operating-model problem, not a technology one.</a:t>
+            </a:r>
+          </a:p>
+        </p:txBody>
+      </p:sp>
+      <p:sp>
+        <p:nvSpPr>
+          <p:cNvPr id="5" name="Rounded Rectangle 4"/>
+          <p:cNvSpPr/>
+          <p:nvPr/>
+        </p:nvSpPr>
+        <p:spPr>
+          <a:xfrm>
+            <a:off x="731520" y="2971800"/>
+            <a:ext cx="4892040" cy="2377440"/>
+          </a:xfrm>
+          <a:prstGeom prst="roundRect">
+            <a:avLst>
+              <a:gd name="adj" fmla="val 4000"/>
+            </a:avLst>
+          </a:prstGeom>
+          <a:solidFill>
+            <a:srgbClr val="F2F2F2"/>
+          </a:solidFill>
+          <a:ln>
+            <a:noFill/>
+          </a:ln>
+          <a:effectLst/>
+        </p:spPr>
+        <p:style>
+          <a:lnRef idx="1">
+            <a:schemeClr val="accent1"/>
+          </a:lnRef>
+          <a:fillRef idx="3">
+            <a:schemeClr val="accent1"/>
+          </a:fillRef>
+          <a:effectRef idx="2">
+            <a:schemeClr val="accent1"/>
+          </a:effectRef>
+          <a:fontRef idx="minor">
+            <a:schemeClr val="lt1"/>
+          </a:fontRef>
+        </p:style>
+        <p:txBody>
+          <a:bodyPr rtlCol="0" anchor="ctr"/>
+          <a:lstStyle/>
+          <a:p>
+            <a:pPr algn="ctr"/>
+          </a:p>
+        </p:txBody>
+      </p:sp>
+      <p:sp>
+        <p:nvSpPr>
+          <p:cNvPr id="6" name="TextBox 5"/>
+          <p:cNvSpPr txBox="1"/>
+          <p:nvPr/>
+        </p:nvSpPr>
+        <p:spPr>
+          <a:xfrm>
+            <a:off x="1051560" y="3200400"/>
+            <a:ext cx="4389120" cy="411480"/>
+          </a:xfrm>
+          <a:prstGeom prst="rect">
+            <a:avLst/>
+          </a:prstGeom>
+          <a:noFill/>
+        </p:spPr>
+        <p:txBody>
+          <a:bodyPr wrap="square" anchor="t">
+            <a:spAutoFit/>
+          </a:bodyPr>
+          <a:lstStyle/>
+          <a:p>
+            <a:pPr algn="l">
+              <a:spcAft>
+                <a:spcPts val="400"/>
+              </a:spcAft>
+            </a:pPr>
+            <a:r>
+              <a:rPr sz="1700" b="1" i="0">
+                <a:solidFill>
+                  <a:srgbClr val="3A3F47"/>
+                </a:solidFill>
+                <a:latin typeface="Arial"/>
+              </a:rPr>
+              <a:t>TREATING AI AS A TOOL</a:t>
+            </a:r>
+          </a:p>
+        </p:txBody>
+      </p:sp>
+      <p:sp>
+        <p:nvSpPr>
+          <p:cNvPr id="7" name="TextBox 6"/>
+          <p:cNvSpPr txBox="1"/>
+          <p:nvPr/>
+        </p:nvSpPr>
+        <p:spPr>
+          <a:xfrm>
+            <a:off x="1051560" y="3703320"/>
+            <a:ext cx="4389120" cy="1554480"/>
+          </a:xfrm>
+          <a:prstGeom prst="rect">
+            <a:avLst/>
+          </a:prstGeom>
+          <a:noFill/>
+        </p:spPr>
+        <p:txBody>
+          <a:bodyPr wrap="square" anchor="t">
+            <a:spAutoFit/>
+          </a:bodyPr>
+          <a:lstStyle/>
+          <a:p>
+            <a:pPr algn="l" marL="201168" indent="-182880">
+              <a:spcAft>
+                <a:spcPts val="500"/>
+              </a:spcAft>
+              <a:buChar char="•"/>
+            </a:pPr>
+            <a:r>
+              <a:rPr sz="1400" b="0" i="0">
+                <a:solidFill>
+                  <a:srgbClr val="3A3F47"/>
+                </a:solidFill>
+                <a:latin typeface="Arial"/>
+              </a:rPr>
+              <a:t>Buy tools, multiply licences</a:t>
+            </a:r>
+          </a:p>
+          <a:p>
+            <a:pPr algn="l" marL="201168" indent="-182880">
+              <a:spcAft>
+                <a:spcPts val="500"/>
+              </a:spcAft>
+              <a:buChar char="•"/>
+            </a:pPr>
+            <a:r>
+              <a:rPr sz="1400" b="0" i="0">
+                <a:solidFill>
+                  <a:srgbClr val="3A3F47"/>
+                </a:solidFill>
+                <a:latin typeface="Arial"/>
+              </a:rPr>
+              <a:t>Train en masse, tick the box</a:t>
+            </a:r>
+          </a:p>
+          <a:p>
+            <a:pPr algn="l" marL="201168" indent="-182880">
+              <a:spcAft>
+                <a:spcPts val="500"/>
+              </a:spcAft>
+              <a:buChar char="•"/>
+            </a:pPr>
+            <a:r>
+              <a:rPr sz="1400" b="0" i="0">
+                <a:solidFill>
+                  <a:srgbClr val="3A3F47"/>
+                </a:solidFill>
+                <a:latin typeface="Arial"/>
+              </a:rPr>
+              <a:t>Count prompts and logins</a:t>
+            </a:r>
+          </a:p>
+          <a:p>
+            <a:pPr algn="l" marL="201168" indent="-182880">
+              <a:spcAft>
+                <a:spcPts val="500"/>
+              </a:spcAft>
+              <a:buChar char="•"/>
+            </a:pPr>
+            <a:r>
+              <a:rPr sz="1400" b="0" i="0">
+                <a:solidFill>
+                  <a:srgbClr val="3A3F47"/>
+                </a:solidFill>
+                <a:latin typeface="Arial"/>
+              </a:rPr>
+              <a:t>Assume adoption follows</a:t>
+            </a:r>
+          </a:p>
+        </p:txBody>
+      </p:sp>
+      <p:sp>
+        <p:nvSpPr>
+          <p:cNvPr id="8" name="Oval 7"/>
+          <p:cNvSpPr/>
+          <p:nvPr/>
+        </p:nvSpPr>
+        <p:spPr>
+          <a:xfrm>
+            <a:off x="5742432" y="3776472"/>
+            <a:ext cx="777240" cy="777240"/>
+          </a:xfrm>
+          <a:prstGeom prst="ellipse">
+            <a:avLst/>
+          </a:prstGeom>
+          <a:solidFill>
+            <a:srgbClr val="CE9A2B"/>
+          </a:solidFill>
+          <a:ln>
+            <a:noFill/>
+          </a:ln>
+          <a:effectLst/>
+        </p:spPr>
+        <p:style>
+          <a:lnRef idx="1">
+            <a:schemeClr val="accent1"/>
+          </a:lnRef>
+          <a:fillRef idx="3">
+            <a:schemeClr val="accent1"/>
+          </a:fillRef>
+          <a:effectRef idx="2">
+            <a:schemeClr val="accent1"/>
+          </a:effectRef>
+          <a:fontRef idx="minor">
+            <a:schemeClr val="lt1"/>
+          </a:fontRef>
+        </p:style>
+        <p:txBody>
+          <a:bodyPr rtlCol="0" anchor="ctr"/>
+          <a:lstStyle/>
+          <a:p>
+            <a:pPr algn="ctr"/>
+          </a:p>
+        </p:txBody>
+      </p:sp>
+      <p:sp>
+        <p:nvSpPr>
+          <p:cNvPr id="9" name="Right Arrow 8"/>
+          <p:cNvSpPr/>
+          <p:nvPr/>
+        </p:nvSpPr>
+        <p:spPr>
+          <a:xfrm>
+            <a:off x="5943600" y="4005072"/>
+            <a:ext cx="384048" cy="329184"/>
+          </a:xfrm>
+          <a:prstGeom prst="rightArrow">
+            <a:avLst/>
+          </a:prstGeom>
+          <a:solidFill>
+            <a:srgbClr val="FFFFFF"/>
+          </a:solidFill>
+          <a:ln>
+            <a:noFill/>
+          </a:ln>
+          <a:effectLst/>
+        </p:spPr>
+        <p:style>
+          <a:lnRef idx="1">
+            <a:schemeClr val="accent1"/>
+          </a:lnRef>
+          <a:fillRef idx="3">
+            <a:schemeClr val="accent1"/>
+          </a:fillRef>
+          <a:effectRef idx="2">
+            <a:schemeClr val="accent1"/>
+          </a:effectRef>
+          <a:fontRef idx="minor">
+            <a:schemeClr val="lt1"/>
+          </a:fontRef>
+        </p:style>
+        <p:txBody>
+          <a:bodyPr rtlCol="0" anchor="ctr"/>
+          <a:lstStyle/>
+          <a:p>
+            <a:pPr algn="ctr"/>
+          </a:p>
+        </p:txBody>
+      </p:sp>
+      <p:sp>
+        <p:nvSpPr>
+          <p:cNvPr id="10" name="Rounded Rectangle 9"/>
+          <p:cNvSpPr/>
+          <p:nvPr/>
+        </p:nvSpPr>
+        <p:spPr>
+          <a:xfrm>
+            <a:off x="6629400" y="2971800"/>
+            <a:ext cx="4892040" cy="2377440"/>
+          </a:xfrm>
+          <a:prstGeom prst="roundRect">
+            <a:avLst>
+              <a:gd name="adj" fmla="val 4000"/>
+            </a:avLst>
+          </a:prstGeom>
+          <a:solidFill>
+            <a:srgbClr val="1F2A5C"/>
+          </a:solidFill>
+          <a:ln>
+            <a:noFill/>
+          </a:ln>
+          <a:effectLst/>
+        </p:spPr>
+        <p:style>
+          <a:lnRef idx="1">
+            <a:schemeClr val="accent1"/>
+          </a:lnRef>
+          <a:fillRef idx="3">
+            <a:schemeClr val="accent1"/>
+          </a:fillRef>
+          <a:effectRef idx="2">
+            <a:schemeClr val="accent1"/>
+          </a:effectRef>
+          <a:fontRef idx="minor">
+            <a:schemeClr val="lt1"/>
+          </a:fontRef>
+        </p:style>
+        <p:txBody>
+          <a:bodyPr rtlCol="0" anchor="ctr"/>
+          <a:lstStyle/>
+          <a:p>
+            <a:pPr algn="ctr"/>
+          </a:p>
+        </p:txBody>
+      </p:sp>
+      <p:sp>
+        <p:nvSpPr>
+          <p:cNvPr id="11" name="TextBox 10"/>
+          <p:cNvSpPr txBox="1"/>
+          <p:nvPr/>
+        </p:nvSpPr>
+        <p:spPr>
+          <a:xfrm>
+            <a:off x="6949440" y="3154680"/>
+            <a:ext cx="4389120" cy="640080"/>
+          </a:xfrm>
+          <a:prstGeom prst="rect">
+            <a:avLst/>
+          </a:prstGeom>
+          <a:noFill/>
+        </p:spPr>
+        <p:txBody>
+          <a:bodyPr wrap="square" anchor="t">
+            <a:spAutoFit/>
+          </a:bodyPr>
+          <a:lstStyle/>
+          <a:p>
+            <a:pPr algn="l">
+              <a:spcAft>
+                <a:spcPts val="400"/>
+              </a:spcAft>
+            </a:pPr>
+            <a:r>
+              <a:rPr sz="1700" b="1" i="0">
+                <a:solidFill>
+                  <a:srgbClr val="CE9A2B"/>
+                </a:solidFill>
+                <a:latin typeface="Arial"/>
+              </a:rPr>
+              <a:t>MAKING IT AN OPERATING-MODEL QUESTION</a:t>
+            </a:r>
+          </a:p>
+        </p:txBody>
+      </p:sp>
+      <p:sp>
+        <p:nvSpPr>
+          <p:cNvPr id="12" name="TextBox 11"/>
+          <p:cNvSpPr txBox="1"/>
+          <p:nvPr/>
+        </p:nvSpPr>
+        <p:spPr>
+          <a:xfrm>
+            <a:off x="6949440" y="3794760"/>
+            <a:ext cx="4389120" cy="1463040"/>
+          </a:xfrm>
+          <a:prstGeom prst="rect">
+            <a:avLst/>
+          </a:prstGeom>
+          <a:noFill/>
+        </p:spPr>
+        <p:txBody>
+          <a:bodyPr wrap="square" anchor="t">
+            <a:spAutoFit/>
+          </a:bodyPr>
+          <a:lstStyle/>
+          <a:p>
+            <a:pPr algn="l" marL="201168" indent="-182880">
+              <a:spcAft>
+                <a:spcPts val="500"/>
+              </a:spcAft>
+              <a:buChar char="•"/>
+            </a:pPr>
+            <a:r>
+              <a:rPr sz="1400" b="0" i="0">
+                <a:solidFill>
+                  <a:srgbClr val="FFFFFF"/>
+                </a:solidFill>
+                <a:latin typeface="Arial"/>
+              </a:rPr>
+              <a:t>Define who owns it and how to govern it</a:t>
+            </a:r>
+          </a:p>
+          <a:p>
+            <a:pPr algn="l" marL="201168" indent="-182880">
+              <a:spcAft>
+                <a:spcPts val="500"/>
+              </a:spcAft>
+              <a:buChar char="•"/>
+            </a:pPr>
+            <a:r>
+              <a:rPr sz="1400" b="0" i="0">
+                <a:solidFill>
+                  <a:srgbClr val="FFFFFF"/>
+                </a:solidFill>
+                <a:latin typeface="Arial"/>
+              </a:rPr>
+              <a:t>Evolve working behaviours</a:t>
+            </a:r>
+          </a:p>
+          <a:p>
+            <a:pPr algn="l" marL="201168" indent="-182880">
+              <a:spcAft>
+                <a:spcPts val="500"/>
+              </a:spcAft>
+              <a:buChar char="•"/>
+            </a:pPr>
+            <a:r>
+              <a:rPr sz="1400" b="0" i="0">
+                <a:solidFill>
+                  <a:srgbClr val="FFFFFF"/>
+                </a:solidFill>
+                <a:latin typeface="Arial"/>
+              </a:rPr>
+              <a:t>Keep humans in the loop</a:t>
+            </a:r>
+          </a:p>
+          <a:p>
+            <a:pPr algn="l" marL="201168" indent="-182880">
+              <a:spcAft>
+                <a:spcPts val="500"/>
+              </a:spcAft>
+              <a:buChar char="•"/>
+            </a:pPr>
+            <a:r>
+              <a:rPr sz="1400" b="0" i="0">
+                <a:solidFill>
+                  <a:srgbClr val="FFFFFF"/>
+                </a:solidFill>
+                <a:latin typeface="Arial"/>
+              </a:rPr>
+              <a:t>Measure impact, not usage</a:t>
+            </a:r>
+          </a:p>
+        </p:txBody>
+      </p:sp>
+      <p:sp>
+        <p:nvSpPr>
+          <p:cNvPr id="13" name="TextBox 12"/>
+          <p:cNvSpPr txBox="1"/>
+          <p:nvPr/>
+        </p:nvSpPr>
+        <p:spPr>
+          <a:xfrm>
+            <a:off x="731520" y="5669280"/>
+            <a:ext cx="10607040" cy="640080"/>
+          </a:xfrm>
+          <a:prstGeom prst="rect">
+            <a:avLst/>
+          </a:prstGeom>
+          <a:noFill/>
+        </p:spPr>
+        <p:txBody>
+          <a:bodyPr wrap="square" anchor="t">
+            <a:spAutoFit/>
+          </a:bodyPr>
+          <a:lstStyle/>
+          <a:p>
+            <a:pPr algn="l">
+              <a:spcAft>
+                <a:spcPts val="400"/>
+              </a:spcAft>
+            </a:pPr>
+            <a:r>
+              <a:rPr sz="1300" b="0" i="1">
+                <a:solidFill>
+                  <a:srgbClr val="1F2A5C"/>
+                </a:solidFill>
+                <a:latin typeface="Arial"/>
+              </a:rPr>
+              <a:t>Today you built one agent and redesigned one process. Neither needed a purchase. Both needed an owner, a limit in code, and a decision about where the person sits.</a:t>
             </a:r>
           </a:p>
         </p:txBody>

</xml_diff>